<commit_message>
Deck: redesigned cover, Century Gothic + Calibri
- Cover leads with the project title (AI-Augmented Security Analysis), company
  tiles with sector icons, a doughnut of P's weights and three key numbers
- Theme fonts Century Gothic (headings, stat callouts) and Calibri (body),
  both shipped with Office on Windows and Mac; '+mj-lt' does not resolve in
  pptxgenjs text runs, so callouts name the heading font from THEME
- Weights written 31 / 19 / 50 (Century Gothic has no matching middle dot)

Co-Authored-By: Claude Opus 5.5 <noreply@anthropic.com>
</commit_message>
<xml_diff>
--- a/deliverables/out/SA_Portfolio_Deck.pptx
+++ b/deliverables/out/SA_Portfolio_Deck.pptx
@@ -119,12 +119,12 @@
   <p:extLst>
     <p:ext uri="{521415D9-36F7-43E2-AB2F-B90AF26B5E84}">
       <p14:sectionLst xmlns:p14="http://schemas.microsoft.com/office/powerpoint/2010/main">
-        <p14:section name="Opening" id="{24b86cf8-6ef0-c843-6a60-1d06c68f6b59}">
+        <p14:section name="Opening" id="{a2ebe612-3b85-6819-1851-0bd92cb33dcf}">
           <p14:sldIdLst>
             <p14:sldId id="256"/>
           </p14:sldIdLst>
         </p14:section>
-        <p14:section name="Analysis" id="{c2ba1796-fc07-84a0-916d-deb79992c8f8}">
+        <p14:section name="Analysis" id="{c594f6af-33d4-89a7-420d-1f9eed2744b9}">
           <p14:sldIdLst>
             <p14:sldId id="257"/>
             <p14:sldId id="258"/>
@@ -133,18 +133,18 @@
             <p14:sldId id="261"/>
           </p14:sldIdLst>
         </p14:section>
-        <p14:section name="Portfolio" id="{2a52df54-8dbe-7e18-db34-79cabe84b741}">
+        <p14:section name="Portfolio" id="{9ccc9df6-dce6-8fd3-0163-8b05b6400012}">
           <p14:sldIdLst>
             <p14:sldId id="262"/>
             <p14:sldId id="263"/>
           </p14:sldIdLst>
         </p14:section>
-        <p14:section name="Close" id="{17b32574-4a0b-cafc-bd58-83211e241a47}">
+        <p14:section name="Close" id="{3092bfba-b834-cb05-a38b-28ebf7d66a21}">
           <p14:sldIdLst>
             <p14:sldId id="264"/>
           </p14:sldIdLst>
         </p14:section>
-        <p14:section name="Appendix" id="{35c9258a-28d2-3e2c-3733-ba94bc987e16}">
+        <p14:section name="Appendix" id="{572450e6-7973-c434-6eb1-5902ad6ac4e2}">
           <p14:sldIdLst>
             <p14:sldId id="265"/>
             <p14:sldId id="266"/>
@@ -162,6 +162,255 @@
 </file>
 
 <file path=ppt/charts/chart1.xml><?xml version="1.0" encoding="utf-8"?>
+<c:chartSpace xmlns:c="http://schemas.openxmlformats.org/drawingml/2006/chart" xmlns:a="http://schemas.openxmlformats.org/drawingml/2006/main" xmlns:r="http://schemas.openxmlformats.org/officeDocument/2006/relationships">
+  <c:date1904 val="0"/>
+  <c:roundedCorners val="1"/>
+  <c:chart>
+    <c:autoTitleDeleted val="1"/>
+    <c:plotArea>
+      <c:layout/>
+      <c:doughnutChart>
+        <c:varyColors val="1"/>
+        <c:ser>
+          <c:idx val="0"/>
+          <c:order val="0"/>
+          <c:tx>
+            <c:strRef>
+              <c:f>Sheet1!$B$1</c:f>
+              <c:strCache>
+                <c:ptCount val="1"/>
+                <c:pt idx="0">
+                  <c:v>Weight in P</c:v>
+                </c:pt>
+              </c:strCache>
+            </c:strRef>
+          </c:tx>
+          <c:spPr>
+            <a:solidFill>
+              <a:schemeClr val="accent1"/>
+            </a:solidFill>
+            <a:ln w="9525" cap="flat">
+              <a:solidFill>
+                <a:srgbClr val="F9F9F9"/>
+              </a:solidFill>
+              <a:prstDash val="solid"/>
+              <a:round/>
+            </a:ln>
+            <a:effectLst/>
+          </c:spPr>
+          <c:dPt>
+            <c:idx val="0"/>
+            <c:bubble3D val="0"/>
+            <c:spPr>
+              <a:solidFill>
+                <a:srgbClr val="3A7C74"/>
+              </a:solidFill>
+              <a:ln w="25400" cap="flat">
+                <a:solidFill>
+                  <a:srgbClr val="1D2C62"/>
+                </a:solidFill>
+                <a:prstDash val="solid"/>
+                <a:round/>
+              </a:ln>
+              <a:effectLst/>
+            </c:spPr>
+          </c:dPt>
+          <c:dPt>
+            <c:idx val="1"/>
+            <c:bubble3D val="0"/>
+            <c:spPr>
+              <a:solidFill>
+                <a:srgbClr val="EBB24D"/>
+              </a:solidFill>
+              <a:ln w="25400" cap="flat">
+                <a:solidFill>
+                  <a:srgbClr val="1D2C62"/>
+                </a:solidFill>
+                <a:prstDash val="solid"/>
+                <a:round/>
+              </a:ln>
+              <a:effectLst/>
+            </c:spPr>
+          </c:dPt>
+          <c:dPt>
+            <c:idx val="2"/>
+            <c:bubble3D val="0"/>
+            <c:spPr>
+              <a:solidFill>
+                <a:srgbClr val="C84D00"/>
+              </a:solidFill>
+              <a:ln w="25400" cap="flat">
+                <a:solidFill>
+                  <a:srgbClr val="1D2C62"/>
+                </a:solidFill>
+                <a:prstDash val="solid"/>
+                <a:round/>
+              </a:ln>
+              <a:effectLst/>
+            </c:spPr>
+          </c:dPt>
+          <c:dLbls>
+            <c:dLbl>
+              <c:idx val="0"/>
+              <c:numFmt formatCode="0%" sourceLinked="0"/>
+              <c:spPr/>
+              <c:txPr>
+                <a:bodyPr/>
+                <a:lstStyle/>
+                <a:p>
+                  <a:pPr>
+                    <a:defRPr sz="1200" b="1" i="0" u="none" strike="noStrike">
+                      <a:solidFill>
+                        <a:srgbClr val="FFFFFF"/>
+                      </a:solidFill>
+                      <a:latin typeface="+mn-lt"/>
+                    </a:defRPr>
+                  </a:pPr>
+                </a:p>
+              </c:txPr>
+              <c:showLegendKey val="0"/>
+              <c:showVal val="0"/>
+              <c:showCatName val="0"/>
+              <c:showSerName val="0"/>
+              <c:showPercent val="1"/>
+              <c:showBubbleSize val="0"/>
+            </c:dLbl>
+            <c:dLbl>
+              <c:idx val="1"/>
+              <c:numFmt formatCode="0%" sourceLinked="0"/>
+              <c:spPr/>
+              <c:txPr>
+                <a:bodyPr/>
+                <a:lstStyle/>
+                <a:p>
+                  <a:pPr>
+                    <a:defRPr sz="1200" b="1" i="0" u="none" strike="noStrike">
+                      <a:solidFill>
+                        <a:srgbClr val="FFFFFF"/>
+                      </a:solidFill>
+                      <a:latin typeface="+mn-lt"/>
+                    </a:defRPr>
+                  </a:pPr>
+                </a:p>
+              </c:txPr>
+              <c:showLegendKey val="0"/>
+              <c:showVal val="0"/>
+              <c:showCatName val="0"/>
+              <c:showSerName val="0"/>
+              <c:showPercent val="1"/>
+              <c:showBubbleSize val="0"/>
+            </c:dLbl>
+            <c:dLbl>
+              <c:idx val="2"/>
+              <c:numFmt formatCode="0%" sourceLinked="0"/>
+              <c:spPr/>
+              <c:txPr>
+                <a:bodyPr/>
+                <a:lstStyle/>
+                <a:p>
+                  <a:pPr>
+                    <a:defRPr sz="1200" b="1" i="0" u="none" strike="noStrike">
+                      <a:solidFill>
+                        <a:srgbClr val="FFFFFF"/>
+                      </a:solidFill>
+                      <a:latin typeface="+mn-lt"/>
+                    </a:defRPr>
+                  </a:pPr>
+                </a:p>
+              </c:txPr>
+              <c:showLegendKey val="0"/>
+              <c:showVal val="0"/>
+              <c:showCatName val="0"/>
+              <c:showSerName val="0"/>
+              <c:showPercent val="1"/>
+              <c:showBubbleSize val="0"/>
+            </c:dLbl>
+            <c:numFmt formatCode="0%" sourceLinked="0"/>
+            <c:txPr>
+              <a:bodyPr/>
+              <a:lstStyle/>
+              <a:p>
+                <a:pPr>
+                  <a:defRPr sz="1800" b="1" i="0" u="none" strike="noStrike">
+                    <a:solidFill>
+                      <a:srgbClr val="000000"/>
+                    </a:solidFill>
+                    <a:latin typeface="Arial"/>
+                  </a:defRPr>
+                </a:pPr>
+              </a:p>
+            </c:txPr>
+            <c:showLegendKey val="0"/>
+            <c:showVal val="0"/>
+            <c:showCatName val="1"/>
+            <c:showSerName val="0"/>
+            <c:showPercent val="1"/>
+            <c:showBubbleSize val="0"/>
+            <c:showLeaderLines val="0"/>
+          </c:dLbls>
+          <c:cat>
+            <c:strRef>
+              <c:f>Sheet1!$A$2:$A$4</c:f>
+              <c:strCache>
+                <c:ptCount val="3"/>
+                <c:pt idx="0">
+                  <c:v>HUL</c:v>
+                </c:pt>
+                <c:pt idx="1">
+                  <c:v>Sun Pharma</c:v>
+                </c:pt>
+                <c:pt idx="2">
+                  <c:v>ICICI Bank</c:v>
+                </c:pt>
+              </c:strCache>
+            </c:strRef>
+          </c:cat>
+          <c:val>
+            <c:numRef>
+              <c:f>Sheet1!$B$2:$B$4</c:f>
+              <c:numCache>
+                <c:ptCount val="3"/>
+                <c:pt idx="0">
+                  <c:v>0.30685972985808274</c:v>
+                </c:pt>
+                <c:pt idx="1">
+                  <c:v>0.19248607535269438</c:v>
+                </c:pt>
+                <c:pt idx="2">
+                  <c:v>0.500654194789223</c:v>
+                </c:pt>
+              </c:numCache>
+            </c:numRef>
+          </c:val>
+        </c:ser>
+        <c:firstSliceAng val="0"/>
+        <c:holeSize val="62"/>
+      </c:doughnutChart>
+      <c:spPr>
+        <a:noFill/>
+        <a:ln>
+          <a:noFill/>
+        </a:ln>
+        <a:effectLst/>
+      </c:spPr>
+    </c:plotArea>
+    <c:plotVisOnly val="1"/>
+    <c:dispBlanksAs val="span"/>
+  </c:chart>
+  <c:spPr>
+    <a:noFill/>
+    <a:ln>
+      <a:noFill/>
+    </a:ln>
+    <a:effectLst/>
+  </c:spPr>
+  <c:externalData r:id="rId1">
+    <c:autoUpdate val="0"/>
+  </c:externalData>
+</c:chartSpace>
+</file>
+
+<file path=ppt/charts/chart2.xml><?xml version="1.0" encoding="utf-8"?>
 <c:chartSpace xmlns:c="http://schemas.openxmlformats.org/drawingml/2006/chart" xmlns:a="http://schemas.openxmlformats.org/drawingml/2006/main" xmlns:r="http://schemas.openxmlformats.org/officeDocument/2006/relationships">
   <c:date1904 val="0"/>
   <c:roundedCorners val="1"/>
@@ -659,7 +908,7 @@
 </c:chartSpace>
 </file>
 
-<file path=ppt/charts/chart2.xml><?xml version="1.0" encoding="utf-8"?>
+<file path=ppt/charts/chart3.xml><?xml version="1.0" encoding="utf-8"?>
 <c:chartSpace xmlns:c="http://schemas.openxmlformats.org/drawingml/2006/chart" xmlns:a="http://schemas.openxmlformats.org/drawingml/2006/main" xmlns:r="http://schemas.openxmlformats.org/officeDocument/2006/relationships">
   <c:date1904 val="0"/>
   <c:roundedCorners val="1"/>
@@ -1487,7 +1736,7 @@
           <a:p>
             <a:r>
               <a:rPr lang="en-US" dirty="0"/>
-              <a:t>[0:30] Ten thousand rupees a month. That is what each of us expects to invest after graduation, and this project asks one question: should that money own Hindustan Unilever, Sun Pharma and ICICI Bank, and how? Our answer has three moves. Pick three businesses whose returns don't move together. Price them honestly: all three trade above our blended values, so we buy slowly. And size the portfolio to each of us: 31, 19, 50 percent, as a satellite around a Nifty index core.</a:t>
+              <a:t>[0:30] Our project is an AI-augmented security analysis of three companies, Hindustan Unilever, Sun Pharma and ICICI Bank, built around one practical question: if each of us invests ten thousand rupees a month after graduation, should that money own them, and how? Our answer has three moves. Pick three businesses whose returns don't move together. Price them honestly: all three trade above our blended values, so we buy slowly. And size the portfolio to each of us: 31, 19, 50 percent, as a satellite around a Nifty index core.</a:t>
             </a:r>
             <a:endParaRPr lang="en-US" dirty="0"/>
           </a:p>
@@ -2744,8 +2993,8 @@
         </p:nvSpPr>
         <p:spPr>
           <a:xfrm>
-            <a:off x="548640" y="1051560"/>
-            <a:ext cx="6949440" cy="1051560"/>
+            <a:off x="548640" y="960120"/>
+            <a:ext cx="6766560" cy="1645920"/>
           </a:xfrm>
           <a:prstGeom prst="rect">
             <a:avLst/>
@@ -2758,7 +3007,7 @@
           <a:lstStyle>
             <a:lvl1pPr algn="l" indent="0" marL="0">
               <a:buNone/>
-              <a:defRPr lang="en-US" sz="6000" b="1" dirty="0">
+              <a:defRPr lang="en-US" sz="4400" b="1" dirty="0">
                 <a:solidFill>
                   <a:schemeClr val="accent1"/>
                 </a:solidFill>
@@ -2769,7 +3018,7 @@
             <a:pPr algn="l" indent="0" marL="0">
               <a:buNone/>
             </a:pPr>
-            <a:endParaRPr lang="en-US" sz="6000" dirty="0"/>
+            <a:endParaRPr lang="en-US" sz="4400" dirty="0"/>
           </a:p>
         </p:txBody>
       </p:sp>
@@ -2783,8 +3032,8 @@
         </p:nvSpPr>
         <p:spPr>
           <a:xfrm>
-            <a:off x="548640" y="2286000"/>
-            <a:ext cx="6675120" cy="1234440"/>
+            <a:off x="548640" y="2743200"/>
+            <a:ext cx="6400800" cy="822960"/>
           </a:xfrm>
           <a:prstGeom prst="rect">
             <a:avLst/>
@@ -2797,7 +3046,7 @@
           <a:lstStyle>
             <a:lvl1pPr algn="l" indent="0" marL="0">
               <a:buNone/>
-              <a:defRPr lang="en-US" sz="2400" b="1" dirty="0">
+              <a:defRPr lang="en-US" sz="1800" dirty="0">
                 <a:solidFill>
                   <a:schemeClr val="tx1"/>
                 </a:solidFill>
@@ -2808,7 +3057,7 @@
             <a:pPr algn="l" indent="0" marL="0">
               <a:buNone/>
             </a:pPr>
-            <a:endParaRPr lang="en-US" sz="2400" dirty="0"/>
+            <a:endParaRPr lang="en-US" sz="1800" dirty="0"/>
           </a:p>
         </p:txBody>
       </p:sp>
@@ -4156,7 +4405,7 @@
                   <a:schemeClr val="tx1"/>
                 </a:solidFill>
               </a:rPr>
-              <a:t>SECURITY ANALYSIS (BBAT35F97) · DATA AS OF 13 OCT 2026</a:t>
+              <a:t>SECURITY ANALYSIS (BBAT35F97) · TAPMI · BBA(H) SEMESTER V</a:t>
             </a:r>
             <a:endParaRPr lang="en-US" sz="1000" dirty="0"/>
           </a:p>
@@ -4172,8 +4421,8 @@
         </p:nvSpPr>
         <p:spPr>
           <a:xfrm>
-            <a:off x="548640" y="1051560"/>
-            <a:ext cx="6949440" cy="1051560"/>
+            <a:off x="548640" y="960120"/>
+            <a:ext cx="6766560" cy="1645920"/>
           </a:xfrm>
           <a:prstGeom prst="rect">
             <a:avLst/>
@@ -4189,14 +4438,14 @@
               <a:buNone/>
             </a:pPr>
             <a:r>
-              <a:rPr lang="en-US" sz="6000" b="1" dirty="0">
+              <a:rPr lang="en-US" sz="4400" b="1" dirty="0">
                 <a:solidFill>
                   <a:schemeClr val="accent1"/>
                 </a:solidFill>
               </a:rPr>
-              <a:t>₹10,000 A MONTH</a:t>
-            </a:r>
-            <a:endParaRPr lang="en-US" sz="6000" dirty="0"/>
+              <a:t>AI-AUGMENTED SECURITY ANALYSIS</a:t>
+            </a:r>
+            <a:endParaRPr lang="en-US" sz="4400" dirty="0"/>
           </a:p>
         </p:txBody>
       </p:sp>
@@ -4210,8 +4459,8 @@
         </p:nvSpPr>
         <p:spPr>
           <a:xfrm>
-            <a:off x="548640" y="2286000"/>
-            <a:ext cx="6675120" cy="1234440"/>
+            <a:off x="548640" y="2743200"/>
+            <a:ext cx="6400800" cy="822960"/>
           </a:xfrm>
           <a:prstGeom prst="rect">
             <a:avLst/>
@@ -4227,264 +4476,636 @@
               <a:buNone/>
             </a:pPr>
             <a:r>
-              <a:rPr lang="en-US" sz="2400" b="1" dirty="0">
+              <a:rPr lang="en-US" sz="1800" dirty="0">
                 <a:solidFill>
                   <a:schemeClr val="tx1"/>
                 </a:solidFill>
               </a:rPr>
-              <a:t>INTO HUL, SUN PHARMA AND ICICI BANK: HOW A STUDENT SHOULD OWN THEM</a:t>
-            </a:r>
-            <a:endParaRPr lang="en-US" sz="2400" dirty="0"/>
-          </a:p>
-        </p:txBody>
-      </p:sp>
-      <p:sp>
-        <p:nvSpPr>
-          <p:cNvPr id="5" name="Text 3"/>
+              <a:t>Valuing Hindustan Unilever, Sun Pharma and ICICI Bank, and building a long-term portfolio from them</a:t>
+            </a:r>
+            <a:endParaRPr lang="en-US" sz="1800" dirty="0"/>
+          </a:p>
+        </p:txBody>
+      </p:sp>
+      <p:sp>
+        <p:nvSpPr>
+          <p:cNvPr id="5" name="cover-HUL"/>
+          <p:cNvSpPr/>
+          <p:nvPr/>
+        </p:nvSpPr>
+        <p:spPr>
+          <a:xfrm>
+            <a:off x="548640" y="3840480"/>
+            <a:ext cx="2103120" cy="1783080"/>
+          </a:xfrm>
+          <a:prstGeom prst="rect">
+            <a:avLst/>
+          </a:prstGeom>
+          <a:solidFill>
+            <a:schemeClr val="bg1"/>
+          </a:solidFill>
+          <a:ln w="9525">
+            <a:solidFill>
+              <a:schemeClr val="accent6"/>
+            </a:solidFill>
+            <a:prstDash val="solid"/>
+          </a:ln>
+        </p:spPr>
+      </p:sp>
+      <p:sp>
+        <p:nvSpPr>
+          <p:cNvPr id="6" name="Shape 4"/>
+          <p:cNvSpPr/>
+          <p:nvPr/>
+        </p:nvSpPr>
+        <p:spPr>
+          <a:xfrm>
+            <a:off x="731520" y="4041648"/>
+            <a:ext cx="566928" cy="566928"/>
+          </a:xfrm>
+          <a:prstGeom prst="ellipse">
+            <a:avLst/>
+          </a:prstGeom>
+          <a:solidFill>
+            <a:schemeClr val="accent3"/>
+          </a:solidFill>
+          <a:ln w="12700">
+            <a:solidFill>
+              <a:schemeClr val="accent3"/>
+            </a:solidFill>
+            <a:prstDash val="solid"/>
+          </a:ln>
+        </p:spPr>
+      </p:sp>
+      <p:pic>
+        <p:nvPicPr>
+          <p:cNvPr id="7" name="cover-icon-HUL" descr="preencoded.png">    </p:cNvPr>
+          <p:cNvPicPr>
+            <a:picLocks noChangeAspect="1"/>
+          </p:cNvPicPr>
+          <p:nvPr/>
+        </p:nvPicPr>
+        <p:blipFill>
+          <a:blip r:embed="rId1"/>
+          <a:stretch>
+            <a:fillRect/>
+          </a:stretch>
+        </p:blipFill>
+        <p:spPr>
+          <a:xfrm>
+            <a:off x="854964" y="4165092"/>
+            <a:ext cx="320040" cy="320040"/>
+          </a:xfrm>
+          <a:prstGeom prst="rect">
+            <a:avLst/>
+          </a:prstGeom>
+        </p:spPr>
+      </p:pic>
+      <p:sp>
+        <p:nvSpPr>
+          <p:cNvPr id="8" name="Text 5"/>
           <p:cNvSpPr txBox="1"/>
           <p:nvPr/>
         </p:nvSpPr>
         <p:spPr>
           <a:xfrm>
-            <a:off x="548640" y="3611880"/>
-            <a:ext cx="6583680" cy="822960"/>
-          </a:xfrm>
-          <a:prstGeom prst="rect">
-            <a:avLst/>
-          </a:prstGeom>
-          <a:noFill/>
-          <a:ln/>
-        </p:spPr>
-        <p:txBody>
-          <a:bodyPr wrap="square" lIns="0" tIns="0" rIns="0" bIns="0" rtlCol="0" anchor="t"/>
-          <a:lstStyle/>
-          <a:p>
-            <a:pPr indent="0" marL="0">
-              <a:buNone/>
-            </a:pPr>
-            <a:r>
-              <a:rPr lang="en-US" sz="1400" dirty="0">
+            <a:off x="1444752" y="4078224"/>
+            <a:ext cx="1143000" cy="548640"/>
+          </a:xfrm>
+          <a:prstGeom prst="rect">
+            <a:avLst/>
+          </a:prstGeom>
+          <a:noFill/>
+          <a:ln/>
+        </p:spPr>
+        <p:txBody>
+          <a:bodyPr wrap="square" lIns="0" tIns="0" rIns="0" bIns="0" rtlCol="0" anchor="t"/>
+          <a:lstStyle/>
+          <a:p>
+            <a:pPr indent="0" marL="0">
+              <a:buNone/>
+            </a:pPr>
+            <a:r>
+              <a:rPr lang="en-US" sz="1000" b="1" spc="100" kern="0" dirty="0">
                 <a:solidFill>
                   <a:schemeClr val="tx2"/>
                 </a:solidFill>
               </a:rPr>
-              <a:t>Median 15-year corpus ₹64.8 lakh from ₹38.1 lakh invested, for a Balanced investor (A = 4), from a 10,000-path Monte Carlo of our portfolio.</a:t>
-            </a:r>
-            <a:endParaRPr lang="en-US" sz="1400" dirty="0"/>
-          </a:p>
-        </p:txBody>
-      </p:sp>
-      <p:sp>
-        <p:nvSpPr>
-          <p:cNvPr id="6" name="Text 4"/>
+              <a:t>FMCG</a:t>
+            </a:r>
+            <a:endParaRPr lang="en-US" sz="1000" dirty="0"/>
+          </a:p>
+          <a:p>
+            <a:pPr indent="0" marL="0">
+              <a:buNone/>
+            </a:pPr>
+            <a:r>
+              <a:rPr lang="en-US" sz="1300" b="1" dirty="0">
+                <a:solidFill>
+                  <a:schemeClr val="tx1"/>
+                </a:solidFill>
+              </a:rPr>
+              <a:t>31% OF P</a:t>
+            </a:r>
+            <a:endParaRPr lang="en-US" sz="1000" dirty="0"/>
+          </a:p>
+        </p:txBody>
+      </p:sp>
+      <p:sp>
+        <p:nvSpPr>
+          <p:cNvPr id="9" name="Text 6"/>
           <p:cNvSpPr txBox="1"/>
           <p:nvPr/>
         </p:nvSpPr>
         <p:spPr>
           <a:xfrm>
-            <a:off x="548640" y="4709160"/>
-            <a:ext cx="2103120" cy="457200"/>
-          </a:xfrm>
-          <a:prstGeom prst="rect">
-            <a:avLst/>
-          </a:prstGeom>
-          <a:noFill/>
-          <a:ln/>
-        </p:spPr>
-        <p:txBody>
-          <a:bodyPr wrap="square" lIns="0" tIns="0" rIns="0" bIns="0" rtlCol="0" anchor="t"/>
-          <a:lstStyle/>
-          <a:p>
-            <a:pPr indent="0" marL="0">
-              <a:buNone/>
-            </a:pPr>
-            <a:r>
-              <a:rPr lang="en-US" sz="2400" b="1" dirty="0">
+            <a:off x="731520" y="4800600"/>
+            <a:ext cx="1828800" cy="320040"/>
+          </a:xfrm>
+          <a:prstGeom prst="rect">
+            <a:avLst/>
+          </a:prstGeom>
+          <a:noFill/>
+          <a:ln/>
+        </p:spPr>
+        <p:txBody>
+          <a:bodyPr wrap="square" lIns="0" tIns="0" rIns="0" bIns="0" rtlCol="0" anchor="t"/>
+          <a:lstStyle/>
+          <a:p>
+            <a:pPr indent="0" marL="0">
+              <a:buNone/>
+            </a:pPr>
+            <a:r>
+              <a:rPr lang="en-US" sz="1500" b="1" dirty="0">
                 <a:solidFill>
                   <a:schemeClr val="tx1"/>
                 </a:solidFill>
               </a:rPr>
-              <a:t>0.34 vs 0.44</a:t>
-            </a:r>
-            <a:endParaRPr lang="en-US" sz="2400" dirty="0"/>
-          </a:p>
-        </p:txBody>
-      </p:sp>
-      <p:sp>
-        <p:nvSpPr>
-          <p:cNvPr id="7" name="Text 5"/>
+              <a:t>Hindustan Unilever</a:t>
+            </a:r>
+            <a:endParaRPr lang="en-US" sz="1500" dirty="0"/>
+          </a:p>
+        </p:txBody>
+      </p:sp>
+      <p:sp>
+        <p:nvSpPr>
+          <p:cNvPr id="10" name="Text 7"/>
           <p:cNvSpPr txBox="1"/>
           <p:nvPr/>
         </p:nvSpPr>
         <p:spPr>
           <a:xfrm>
-            <a:off x="548640" y="5193792"/>
-            <a:ext cx="2011680" cy="457200"/>
-          </a:xfrm>
-          <a:prstGeom prst="rect">
-            <a:avLst/>
-          </a:prstGeom>
-          <a:noFill/>
-          <a:ln/>
-        </p:spPr>
-        <p:txBody>
-          <a:bodyPr wrap="square" lIns="0" tIns="0" rIns="0" bIns="0" rtlCol="0" anchor="t"/>
-          <a:lstStyle/>
-          <a:p>
-            <a:pPr indent="0" marL="0">
-              <a:buNone/>
-            </a:pPr>
-            <a:r>
-              <a:rPr lang="en-US" sz="1000" b="1" dirty="0">
+            <a:off x="731520" y="5166360"/>
+            <a:ext cx="1828800" cy="274320"/>
+          </a:xfrm>
+          <a:prstGeom prst="rect">
+            <a:avLst/>
+          </a:prstGeom>
+          <a:noFill/>
+          <a:ln/>
+        </p:spPr>
+        <p:txBody>
+          <a:bodyPr wrap="square" lIns="0" tIns="0" rIns="0" bIns="0" rtlCol="0" anchor="t"/>
+          <a:lstStyle/>
+          <a:p>
+            <a:pPr indent="0" marL="0">
+              <a:buNone/>
+            </a:pPr>
+            <a:r>
+              <a:rPr lang="en-US" sz="1100" dirty="0">
                 <a:solidFill>
                   <a:schemeClr val="tx2"/>
                 </a:solidFill>
               </a:rPr>
-              <a:t>SHARPE RATIO: OUR 3 STOCKS VS THE NIFTY</a:t>
+              <a:t>β 0.60 · CAGR 9.6%</a:t>
+            </a:r>
+            <a:endParaRPr lang="en-US" sz="1100" dirty="0"/>
+          </a:p>
+        </p:txBody>
+      </p:sp>
+      <p:sp>
+        <p:nvSpPr>
+          <p:cNvPr id="11" name="cover-Sun Pharma"/>
+          <p:cNvSpPr/>
+          <p:nvPr/>
+        </p:nvSpPr>
+        <p:spPr>
+          <a:xfrm>
+            <a:off x="2834640" y="3840480"/>
+            <a:ext cx="2103120" cy="1783080"/>
+          </a:xfrm>
+          <a:prstGeom prst="rect">
+            <a:avLst/>
+          </a:prstGeom>
+          <a:solidFill>
+            <a:schemeClr val="bg1"/>
+          </a:solidFill>
+          <a:ln w="9525">
+            <a:solidFill>
+              <a:schemeClr val="accent6"/>
+            </a:solidFill>
+            <a:prstDash val="solid"/>
+          </a:ln>
+        </p:spPr>
+      </p:sp>
+      <p:sp>
+        <p:nvSpPr>
+          <p:cNvPr id="12" name="Shape 9"/>
+          <p:cNvSpPr/>
+          <p:nvPr/>
+        </p:nvSpPr>
+        <p:spPr>
+          <a:xfrm>
+            <a:off x="3017520" y="4041648"/>
+            <a:ext cx="566928" cy="566928"/>
+          </a:xfrm>
+          <a:prstGeom prst="ellipse">
+            <a:avLst/>
+          </a:prstGeom>
+          <a:solidFill>
+            <a:schemeClr val="accent2"/>
+          </a:solidFill>
+          <a:ln w="12700">
+            <a:solidFill>
+              <a:schemeClr val="accent2"/>
+            </a:solidFill>
+            <a:prstDash val="solid"/>
+          </a:ln>
+        </p:spPr>
+      </p:sp>
+      <p:pic>
+        <p:nvPicPr>
+          <p:cNvPr id="13" name="cover-icon-Sun Pharma" descr="preencoded.png">    </p:cNvPr>
+          <p:cNvPicPr>
+            <a:picLocks noChangeAspect="1"/>
+          </p:cNvPicPr>
+          <p:nvPr/>
+        </p:nvPicPr>
+        <p:blipFill>
+          <a:blip r:embed="rId2"/>
+          <a:stretch>
+            <a:fillRect/>
+          </a:stretch>
+        </p:blipFill>
+        <p:spPr>
+          <a:xfrm>
+            <a:off x="3140964" y="4165092"/>
+            <a:ext cx="320040" cy="320040"/>
+          </a:xfrm>
+          <a:prstGeom prst="rect">
+            <a:avLst/>
+          </a:prstGeom>
+        </p:spPr>
+      </p:pic>
+      <p:sp>
+        <p:nvSpPr>
+          <p:cNvPr id="14" name="Text 10"/>
+          <p:cNvSpPr txBox="1"/>
+          <p:nvPr/>
+        </p:nvSpPr>
+        <p:spPr>
+          <a:xfrm>
+            <a:off x="3730752" y="4078224"/>
+            <a:ext cx="1143000" cy="548640"/>
+          </a:xfrm>
+          <a:prstGeom prst="rect">
+            <a:avLst/>
+          </a:prstGeom>
+          <a:noFill/>
+          <a:ln/>
+        </p:spPr>
+        <p:txBody>
+          <a:bodyPr wrap="square" lIns="0" tIns="0" rIns="0" bIns="0" rtlCol="0" anchor="t"/>
+          <a:lstStyle/>
+          <a:p>
+            <a:pPr indent="0" marL="0">
+              <a:buNone/>
+            </a:pPr>
+            <a:r>
+              <a:rPr lang="en-US" sz="1000" b="1" spc="100" kern="0" dirty="0">
+                <a:solidFill>
+                  <a:schemeClr val="tx2"/>
+                </a:solidFill>
+              </a:rPr>
+              <a:t>PHARMA</a:t>
             </a:r>
             <a:endParaRPr lang="en-US" sz="1000" dirty="0"/>
           </a:p>
-        </p:txBody>
-      </p:sp>
-      <p:sp>
-        <p:nvSpPr>
-          <p:cNvPr id="8" name="Text 6"/>
+          <a:p>
+            <a:pPr indent="0" marL="0">
+              <a:buNone/>
+            </a:pPr>
+            <a:r>
+              <a:rPr lang="en-US" sz="1300" b="1" dirty="0">
+                <a:solidFill>
+                  <a:schemeClr val="tx1"/>
+                </a:solidFill>
+              </a:rPr>
+              <a:t>19% OF P</a:t>
+            </a:r>
+            <a:endParaRPr lang="en-US" sz="1000" dirty="0"/>
+          </a:p>
+        </p:txBody>
+      </p:sp>
+      <p:sp>
+        <p:nvSpPr>
+          <p:cNvPr id="15" name="Text 11"/>
           <p:cNvSpPr txBox="1"/>
           <p:nvPr/>
         </p:nvSpPr>
         <p:spPr>
           <a:xfrm>
-            <a:off x="2788920" y="4709160"/>
-            <a:ext cx="2103120" cy="457200"/>
-          </a:xfrm>
-          <a:prstGeom prst="rect">
-            <a:avLst/>
-          </a:prstGeom>
-          <a:noFill/>
-          <a:ln/>
-        </p:spPr>
-        <p:txBody>
-          <a:bodyPr wrap="square" lIns="0" tIns="0" rIns="0" bIns="0" rtlCol="0" anchor="t"/>
-          <a:lstStyle/>
-          <a:p>
-            <a:pPr indent="0" marL="0">
-              <a:buNone/>
-            </a:pPr>
-            <a:r>
-              <a:rPr lang="en-US" sz="2400" b="1" dirty="0">
+            <a:off x="3017520" y="4800600"/>
+            <a:ext cx="1828800" cy="320040"/>
+          </a:xfrm>
+          <a:prstGeom prst="rect">
+            <a:avLst/>
+          </a:prstGeom>
+          <a:noFill/>
+          <a:ln/>
+        </p:spPr>
+        <p:txBody>
+          <a:bodyPr wrap="square" lIns="0" tIns="0" rIns="0" bIns="0" rtlCol="0" anchor="t"/>
+          <a:lstStyle/>
+          <a:p>
+            <a:pPr indent="0" marL="0">
+              <a:buNone/>
+            </a:pPr>
+            <a:r>
+              <a:rPr lang="en-US" sz="1500" b="1" dirty="0">
                 <a:solidFill>
                   <a:schemeClr val="tx1"/>
                 </a:solidFill>
               </a:rPr>
-              <a:t>44 / 47</a:t>
-            </a:r>
-            <a:endParaRPr lang="en-US" sz="2400" dirty="0"/>
-          </a:p>
-        </p:txBody>
-      </p:sp>
-      <p:sp>
-        <p:nvSpPr>
-          <p:cNvPr id="9" name="Text 7"/>
+              <a:t>Sun Pharma</a:t>
+            </a:r>
+            <a:endParaRPr lang="en-US" sz="1500" dirty="0"/>
+          </a:p>
+        </p:txBody>
+      </p:sp>
+      <p:sp>
+        <p:nvSpPr>
+          <p:cNvPr id="16" name="Text 12"/>
           <p:cNvSpPr txBox="1"/>
           <p:nvPr/>
         </p:nvSpPr>
         <p:spPr>
           <a:xfrm>
-            <a:off x="2788920" y="5193792"/>
-            <a:ext cx="2011680" cy="457200"/>
-          </a:xfrm>
-          <a:prstGeom prst="rect">
-            <a:avLst/>
-          </a:prstGeom>
-          <a:noFill/>
-          <a:ln/>
-        </p:spPr>
-        <p:txBody>
-          <a:bodyPr wrap="square" lIns="0" tIns="0" rIns="0" bIns="0" rtlCol="0" anchor="t"/>
-          <a:lstStyle/>
-          <a:p>
-            <a:pPr indent="0" marL="0">
-              <a:buNone/>
-            </a:pPr>
-            <a:r>
-              <a:rPr lang="en-US" sz="1000" b="1" dirty="0">
+            <a:off x="3017520" y="5166360"/>
+            <a:ext cx="1828800" cy="274320"/>
+          </a:xfrm>
+          <a:prstGeom prst="rect">
+            <a:avLst/>
+          </a:prstGeom>
+          <a:noFill/>
+          <a:ln/>
+        </p:spPr>
+        <p:txBody>
+          <a:bodyPr wrap="square" lIns="0" tIns="0" rIns="0" bIns="0" rtlCol="0" anchor="t"/>
+          <a:lstStyle/>
+          <a:p>
+            <a:pPr indent="0" marL="0">
+              <a:buNone/>
+            </a:pPr>
+            <a:r>
+              <a:rPr lang="en-US" sz="1100" dirty="0">
                 <a:solidFill>
                   <a:schemeClr val="tx2"/>
                 </a:solidFill>
               </a:rPr>
-              <a:t>AI-EXTRACTED FIGURES WITHIN 1%</a:t>
+              <a:t>β 0.65 · CAGR 8.7%</a:t>
+            </a:r>
+            <a:endParaRPr lang="en-US" sz="1100" dirty="0"/>
+          </a:p>
+        </p:txBody>
+      </p:sp>
+      <p:sp>
+        <p:nvSpPr>
+          <p:cNvPr id="17" name="cover-ICICI Bank"/>
+          <p:cNvSpPr/>
+          <p:nvPr/>
+        </p:nvSpPr>
+        <p:spPr>
+          <a:xfrm>
+            <a:off x="5120640" y="3840480"/>
+            <a:ext cx="2103120" cy="1783080"/>
+          </a:xfrm>
+          <a:prstGeom prst="rect">
+            <a:avLst/>
+          </a:prstGeom>
+          <a:solidFill>
+            <a:schemeClr val="bg1"/>
+          </a:solidFill>
+          <a:ln w="9525">
+            <a:solidFill>
+              <a:schemeClr val="accent6"/>
+            </a:solidFill>
+            <a:prstDash val="solid"/>
+          </a:ln>
+        </p:spPr>
+      </p:sp>
+      <p:sp>
+        <p:nvSpPr>
+          <p:cNvPr id="18" name="Shape 14"/>
+          <p:cNvSpPr/>
+          <p:nvPr/>
+        </p:nvSpPr>
+        <p:spPr>
+          <a:xfrm>
+            <a:off x="5303520" y="4041648"/>
+            <a:ext cx="566928" cy="566928"/>
+          </a:xfrm>
+          <a:prstGeom prst="ellipse">
+            <a:avLst/>
+          </a:prstGeom>
+          <a:solidFill>
+            <a:schemeClr val="accent1"/>
+          </a:solidFill>
+          <a:ln w="12700">
+            <a:solidFill>
+              <a:schemeClr val="accent1"/>
+            </a:solidFill>
+            <a:prstDash val="solid"/>
+          </a:ln>
+        </p:spPr>
+      </p:sp>
+      <p:pic>
+        <p:nvPicPr>
+          <p:cNvPr id="19" name="cover-icon-ICICI Bank" descr="preencoded.png">    </p:cNvPr>
+          <p:cNvPicPr>
+            <a:picLocks noChangeAspect="1"/>
+          </p:cNvPicPr>
+          <p:nvPr/>
+        </p:nvPicPr>
+        <p:blipFill>
+          <a:blip r:embed="rId3"/>
+          <a:stretch>
+            <a:fillRect/>
+          </a:stretch>
+        </p:blipFill>
+        <p:spPr>
+          <a:xfrm>
+            <a:off x="5426964" y="4165092"/>
+            <a:ext cx="320040" cy="320040"/>
+          </a:xfrm>
+          <a:prstGeom prst="rect">
+            <a:avLst/>
+          </a:prstGeom>
+        </p:spPr>
+      </p:pic>
+      <p:sp>
+        <p:nvSpPr>
+          <p:cNvPr id="20" name="Text 15"/>
+          <p:cNvSpPr txBox="1"/>
+          <p:nvPr/>
+        </p:nvSpPr>
+        <p:spPr>
+          <a:xfrm>
+            <a:off x="6016752" y="4078224"/>
+            <a:ext cx="1143000" cy="548640"/>
+          </a:xfrm>
+          <a:prstGeom prst="rect">
+            <a:avLst/>
+          </a:prstGeom>
+          <a:noFill/>
+          <a:ln/>
+        </p:spPr>
+        <p:txBody>
+          <a:bodyPr wrap="square" lIns="0" tIns="0" rIns="0" bIns="0" rtlCol="0" anchor="t"/>
+          <a:lstStyle/>
+          <a:p>
+            <a:pPr indent="0" marL="0">
+              <a:buNone/>
+            </a:pPr>
+            <a:r>
+              <a:rPr lang="en-US" sz="1000" b="1" spc="100" kern="0" dirty="0">
+                <a:solidFill>
+                  <a:schemeClr val="tx2"/>
+                </a:solidFill>
+              </a:rPr>
+              <a:t>PRIVATE BANK</a:t>
             </a:r>
             <a:endParaRPr lang="en-US" sz="1000" dirty="0"/>
           </a:p>
-        </p:txBody>
-      </p:sp>
-      <p:sp>
-        <p:nvSpPr>
-          <p:cNvPr id="10" name="Text 8"/>
+          <a:p>
+            <a:pPr indent="0" marL="0">
+              <a:buNone/>
+            </a:pPr>
+            <a:r>
+              <a:rPr lang="en-US" sz="1300" b="1" dirty="0">
+                <a:solidFill>
+                  <a:schemeClr val="tx1"/>
+                </a:solidFill>
+              </a:rPr>
+              <a:t>50% OF P</a:t>
+            </a:r>
+            <a:endParaRPr lang="en-US" sz="1000" dirty="0"/>
+          </a:p>
+        </p:txBody>
+      </p:sp>
+      <p:sp>
+        <p:nvSpPr>
+          <p:cNvPr id="21" name="Text 16"/>
           <p:cNvSpPr txBox="1"/>
           <p:nvPr/>
         </p:nvSpPr>
         <p:spPr>
           <a:xfrm>
-            <a:off x="5029200" y="4709160"/>
-            <a:ext cx="2103120" cy="457200"/>
-          </a:xfrm>
-          <a:prstGeom prst="rect">
-            <a:avLst/>
-          </a:prstGeom>
-          <a:noFill/>
-          <a:ln/>
-        </p:spPr>
-        <p:txBody>
-          <a:bodyPr wrap="square" lIns="0" tIns="0" rIns="0" bIns="0" rtlCol="0" anchor="t"/>
-          <a:lstStyle/>
-          <a:p>
-            <a:pPr indent="0" marL="0">
-              <a:buNone/>
-            </a:pPr>
-            <a:r>
-              <a:rPr lang="en-US" sz="2400" b="1" dirty="0">
+            <a:off x="5303520" y="4800600"/>
+            <a:ext cx="1828800" cy="320040"/>
+          </a:xfrm>
+          <a:prstGeom prst="rect">
+            <a:avLst/>
+          </a:prstGeom>
+          <a:noFill/>
+          <a:ln/>
+        </p:spPr>
+        <p:txBody>
+          <a:bodyPr wrap="square" lIns="0" tIns="0" rIns="0" bIns="0" rtlCol="0" anchor="t"/>
+          <a:lstStyle/>
+          <a:p>
+            <a:pPr indent="0" marL="0">
+              <a:buNone/>
+            </a:pPr>
+            <a:r>
+              <a:rPr lang="en-US" sz="1500" b="1" dirty="0">
                 <a:solidFill>
                   <a:schemeClr val="tx1"/>
                 </a:solidFill>
               </a:rPr>
-              <a:t>0 of 8</a:t>
-            </a:r>
-            <a:endParaRPr lang="en-US" sz="2400" dirty="0"/>
-          </a:p>
-        </p:txBody>
-      </p:sp>
-      <p:sp>
-        <p:nvSpPr>
-          <p:cNvPr id="11" name="Text 9"/>
+              <a:t>ICICI Bank</a:t>
+            </a:r>
+            <a:endParaRPr lang="en-US" sz="1500" dirty="0"/>
+          </a:p>
+        </p:txBody>
+      </p:sp>
+      <p:sp>
+        <p:nvSpPr>
+          <p:cNvPr id="22" name="Text 17"/>
           <p:cNvSpPr txBox="1"/>
           <p:nvPr/>
         </p:nvSpPr>
         <p:spPr>
           <a:xfrm>
-            <a:off x="5029200" y="5193792"/>
-            <a:ext cx="2011680" cy="457200"/>
-          </a:xfrm>
-          <a:prstGeom prst="rect">
-            <a:avLst/>
-          </a:prstGeom>
-          <a:noFill/>
-          <a:ln/>
-        </p:spPr>
-        <p:txBody>
-          <a:bodyPr wrap="square" lIns="0" tIns="0" rIns="0" bIns="0" rtlCol="0" anchor="t"/>
-          <a:lstStyle/>
-          <a:p>
-            <a:pPr indent="0" marL="0">
-              <a:buNone/>
-            </a:pPr>
-            <a:r>
-              <a:rPr lang="en-US" sz="1000" b="1" dirty="0">
+            <a:off x="5303520" y="5166360"/>
+            <a:ext cx="1828800" cy="274320"/>
+          </a:xfrm>
+          <a:prstGeom prst="rect">
+            <a:avLst/>
+          </a:prstGeom>
+          <a:noFill/>
+          <a:ln/>
+        </p:spPr>
+        <p:txBody>
+          <a:bodyPr wrap="square" lIns="0" tIns="0" rIns="0" bIns="0" rtlCol="0" anchor="t"/>
+          <a:lstStyle/>
+          <a:p>
+            <a:pPr indent="0" marL="0">
+              <a:buNone/>
+            </a:pPr>
+            <a:r>
+              <a:rPr lang="en-US" sz="1100" dirty="0">
                 <a:solidFill>
                   <a:schemeClr val="tx2"/>
                 </a:solidFill>
               </a:rPr>
-              <a:t>TRADING RULES THAT BEAT BUY-AND-HOLD</a:t>
+              <a:t>β 1.29 · CAGR 19.1%</a:t>
+            </a:r>
+            <a:endParaRPr lang="en-US" sz="1100" dirty="0"/>
+          </a:p>
+        </p:txBody>
+      </p:sp>
+      <p:sp>
+        <p:nvSpPr>
+          <p:cNvPr id="23" name="Text 18"/>
+          <p:cNvSpPr txBox="1"/>
+          <p:nvPr/>
+        </p:nvSpPr>
+        <p:spPr>
+          <a:xfrm>
+            <a:off x="548640" y="6172200"/>
+            <a:ext cx="5669280" cy="274320"/>
+          </a:xfrm>
+          <a:prstGeom prst="rect">
+            <a:avLst/>
+          </a:prstGeom>
+          <a:noFill/>
+          <a:ln/>
+        </p:spPr>
+        <p:txBody>
+          <a:bodyPr wrap="square" lIns="0" tIns="0" rIns="0" bIns="0" rtlCol="0" anchor="t"/>
+          <a:lstStyle/>
+          <a:p>
+            <a:pPr indent="0" marL="0">
+              <a:buNone/>
+            </a:pPr>
+            <a:r>
+              <a:rPr lang="en-US" sz="1000" b="1" spc="150" kern="0" dirty="0">
+                <a:solidFill>
+                  <a:schemeClr val="tx2"/>
+                </a:solidFill>
+              </a:rPr>
+              <a:t>GROUP PROJECT · DATA AS OF 13 OCT 2026</a:t>
             </a:r>
             <a:endParaRPr lang="en-US" sz="1000" dirty="0"/>
           </a:p>
@@ -4492,14 +5113,14 @@
       </p:sp>
       <p:sp>
         <p:nvSpPr>
-          <p:cNvPr id="12" name="Text 10"/>
+          <p:cNvPr id="24" name="Text 19"/>
           <p:cNvSpPr txBox="1"/>
           <p:nvPr/>
         </p:nvSpPr>
         <p:spPr>
           <a:xfrm>
-            <a:off x="548640" y="6172200"/>
-            <a:ext cx="6766560" cy="274320"/>
+            <a:off x="8229600" y="1097280"/>
+            <a:ext cx="3474720" cy="274320"/>
           </a:xfrm>
           <a:prstGeom prst="rect">
             <a:avLst/>
@@ -4517,46 +5138,101 @@
             <a:r>
               <a:rPr lang="en-US" sz="1000" b="1" spc="150" kern="0" dirty="0">
                 <a:solidFill>
-                  <a:schemeClr val="tx1"/>
-                </a:solidFill>
-              </a:rPr>
-              <a:t>TAPMI · BBA(H) SEMESTER V · GROUP PROJECT</a:t>
+                  <a:schemeClr val="accent2"/>
+                </a:solidFill>
+              </a:rPr>
+              <a:t>THE PORTFOLIO WE BUILT</a:t>
             </a:r>
             <a:endParaRPr lang="en-US" sz="1000" dirty="0"/>
           </a:p>
         </p:txBody>
       </p:sp>
-      <p:sp>
-        <p:nvSpPr>
-          <p:cNvPr id="13" name="Text 11"/>
+      <p:graphicFrame>
+        <p:nvGraphicFramePr>
+          <p:cNvPr id="25" name="cover-weights" descr=""/>
+          <p:cNvGraphicFramePr/>
+          <p:nvPr/>
+        </p:nvGraphicFramePr>
+        <p:xfrm>
+          <a:off x="8595360" y="1371600"/>
+          <a:ext cx="2697480" cy="2697480"/>
+        </p:xfrm>
+        <a:graphic xmlns:a="http://schemas.openxmlformats.org/drawingml/2006/main">
+          <a:graphicData uri="http://schemas.openxmlformats.org/drawingml/2006/chart">
+            <c:chart xmlns:c="http://schemas.openxmlformats.org/drawingml/2006/chart" r:id="rId4"/>
+          </a:graphicData>
+        </a:graphic>
+      </p:graphicFrame>
+      <p:sp>
+        <p:nvSpPr>
+          <p:cNvPr id="26" name="Text 20"/>
           <p:cNvSpPr txBox="1"/>
           <p:nvPr/>
         </p:nvSpPr>
         <p:spPr>
           <a:xfrm>
-            <a:off x="8229600" y="1234440"/>
-            <a:ext cx="3383280" cy="274320"/>
-          </a:xfrm>
-          <a:prstGeom prst="rect">
-            <a:avLst/>
-          </a:prstGeom>
-          <a:noFill/>
-          <a:ln/>
-        </p:spPr>
-        <p:txBody>
-          <a:bodyPr wrap="square" lIns="0" tIns="0" rIns="0" bIns="0" rtlCol="0" anchor="t"/>
-          <a:lstStyle/>
-          <a:p>
-            <a:pPr indent="0" marL="0">
-              <a:buNone/>
-            </a:pPr>
-            <a:r>
-              <a:rPr lang="en-US" sz="1000" b="1" spc="150" kern="0" dirty="0">
-                <a:solidFill>
-                  <a:schemeClr val="accent2"/>
-                </a:solidFill>
-              </a:rPr>
-              <a:t>OUR ANSWER IN THREE MOVES</a:t>
+            <a:off x="9395460" y="2331720"/>
+            <a:ext cx="1097280" cy="502920"/>
+          </a:xfrm>
+          <a:prstGeom prst="rect">
+            <a:avLst/>
+          </a:prstGeom>
+          <a:noFill/>
+          <a:ln/>
+        </p:spPr>
+        <p:txBody>
+          <a:bodyPr wrap="square" lIns="0" tIns="0" rIns="0" bIns="0" rtlCol="0" anchor="t"/>
+          <a:lstStyle/>
+          <a:p>
+            <a:pPr algn="ctr" indent="0" marL="0">
+              <a:buNone/>
+            </a:pPr>
+            <a:r>
+              <a:rPr lang="en-US" sz="3000" b="1" dirty="0">
+                <a:solidFill>
+                  <a:schemeClr val="bg1"/>
+                </a:solidFill>
+                <a:latin typeface="Century Gothic" pitchFamily="34" charset="0"/>
+                <a:ea typeface="Century Gothic" pitchFamily="34" charset="-122"/>
+                <a:cs typeface="Century Gothic" pitchFamily="34" charset="-120"/>
+              </a:rPr>
+              <a:t>P</a:t>
+            </a:r>
+            <a:endParaRPr lang="en-US" sz="3000" dirty="0"/>
+          </a:p>
+        </p:txBody>
+      </p:sp>
+      <p:sp>
+        <p:nvSpPr>
+          <p:cNvPr id="27" name="Text 21"/>
+          <p:cNvSpPr txBox="1"/>
+          <p:nvPr/>
+        </p:nvSpPr>
+        <p:spPr>
+          <a:xfrm>
+            <a:off x="9212580" y="2834640"/>
+            <a:ext cx="1463040" cy="274320"/>
+          </a:xfrm>
+          <a:prstGeom prst="rect">
+            <a:avLst/>
+          </a:prstGeom>
+          <a:noFill/>
+          <a:ln/>
+        </p:spPr>
+        <p:txBody>
+          <a:bodyPr wrap="square" lIns="0" tIns="0" rIns="0" bIns="0" rtlCol="0" anchor="t"/>
+          <a:lstStyle/>
+          <a:p>
+            <a:pPr algn="ctr" indent="0" marL="0">
+              <a:buNone/>
+            </a:pPr>
+            <a:r>
+              <a:rPr lang="en-US" sz="1000" b="1" spc="100" kern="0" dirty="0">
+                <a:solidFill>
+                  <a:schemeClr val="accent6"/>
+                </a:solidFill>
+              </a:rPr>
+              <a:t>SHARPE 0.34</a:t>
             </a:r>
             <a:endParaRPr lang="en-US" sz="1000" dirty="0"/>
           </a:p>
@@ -4564,122 +5240,14 @@
       </p:sp>
       <p:sp>
         <p:nvSpPr>
-          <p:cNvPr id="14" name="Text 12"/>
-          <p:cNvSpPr txBox="1"/>
-          <p:nvPr/>
-        </p:nvSpPr>
-        <p:spPr>
-          <a:xfrm>
-            <a:off x="8229600" y="1737360"/>
-            <a:ext cx="457200" cy="274320"/>
-          </a:xfrm>
-          <a:prstGeom prst="rect">
-            <a:avLst/>
-          </a:prstGeom>
-          <a:noFill/>
-          <a:ln/>
-        </p:spPr>
-        <p:txBody>
-          <a:bodyPr wrap="square" lIns="0" tIns="0" rIns="0" bIns="0" rtlCol="0" anchor="t"/>
-          <a:lstStyle/>
-          <a:p>
-            <a:pPr indent="0" marL="0">
-              <a:buNone/>
-            </a:pPr>
-            <a:r>
-              <a:rPr lang="en-US" sz="1100" b="1" dirty="0">
-                <a:solidFill>
-                  <a:schemeClr val="accent2"/>
-                </a:solidFill>
-              </a:rPr>
-              <a:t>01</a:t>
-            </a:r>
-            <a:endParaRPr lang="en-US" sz="1100" dirty="0"/>
-          </a:p>
-        </p:txBody>
-      </p:sp>
-      <p:sp>
-        <p:nvSpPr>
-          <p:cNvPr id="15" name="Text 13"/>
-          <p:cNvSpPr txBox="1"/>
-          <p:nvPr/>
-        </p:nvSpPr>
-        <p:spPr>
-          <a:xfrm>
-            <a:off x="8732520" y="1691640"/>
-            <a:ext cx="2926080" cy="365760"/>
-          </a:xfrm>
-          <a:prstGeom prst="rect">
-            <a:avLst/>
-          </a:prstGeom>
-          <a:noFill/>
-          <a:ln/>
-        </p:spPr>
-        <p:txBody>
-          <a:bodyPr wrap="square" lIns="0" tIns="0" rIns="0" bIns="0" rtlCol="0" anchor="t"/>
-          <a:lstStyle/>
-          <a:p>
-            <a:pPr indent="0" marL="0">
-              <a:buNone/>
-            </a:pPr>
-            <a:r>
-              <a:rPr lang="en-US" sz="2000" b="1" dirty="0">
-                <a:solidFill>
-                  <a:schemeClr val="bg1"/>
-                </a:solidFill>
-              </a:rPr>
-              <a:t>PICK</a:t>
-            </a:r>
-            <a:endParaRPr lang="en-US" sz="2000" dirty="0"/>
-          </a:p>
-        </p:txBody>
-      </p:sp>
-      <p:sp>
-        <p:nvSpPr>
-          <p:cNvPr id="16" name="Text 14"/>
-          <p:cNvSpPr txBox="1"/>
-          <p:nvPr/>
-        </p:nvSpPr>
-        <p:spPr>
-          <a:xfrm>
-            <a:off x="8732520" y="2103120"/>
-            <a:ext cx="2926080" cy="502920"/>
-          </a:xfrm>
-          <a:prstGeom prst="rect">
-            <a:avLst/>
-          </a:prstGeom>
-          <a:noFill/>
-          <a:ln/>
-        </p:spPr>
-        <p:txBody>
-          <a:bodyPr wrap="square" lIns="0" tIns="0" rIns="0" bIns="0" rtlCol="0" anchor="t"/>
-          <a:lstStyle/>
-          <a:p>
-            <a:pPr indent="0" marL="0">
-              <a:buNone/>
-            </a:pPr>
-            <a:r>
-              <a:rPr lang="en-US" sz="1200" dirty="0">
-                <a:solidFill>
-                  <a:schemeClr val="accent6"/>
-                </a:solidFill>
-              </a:rPr>
-              <a:t>Three sectors, three macro drivers, correlations of 0.16–0.24</a:t>
-            </a:r>
-            <a:endParaRPr lang="en-US" sz="1200" dirty="0"/>
-          </a:p>
-        </p:txBody>
-      </p:sp>
-      <p:sp>
-        <p:nvSpPr>
-          <p:cNvPr id="17" name="Shape 15"/>
+          <p:cNvPr id="28" name="Shape 22"/>
           <p:cNvSpPr/>
           <p:nvPr/>
         </p:nvSpPr>
         <p:spPr>
           <a:xfrm>
-            <a:off x="8229600" y="2679192"/>
-            <a:ext cx="3410712" cy="0"/>
+            <a:off x="8229600" y="4206240"/>
+            <a:ext cx="3520440" cy="0"/>
           </a:xfrm>
           <a:prstGeom prst="line">
             <a:avLst/>
@@ -4695,122 +5263,89 @@
       </p:sp>
       <p:sp>
         <p:nvSpPr>
-          <p:cNvPr id="18" name="Text 16"/>
+          <p:cNvPr id="29" name="Text 23"/>
           <p:cNvSpPr txBox="1"/>
           <p:nvPr/>
         </p:nvSpPr>
         <p:spPr>
           <a:xfrm>
-            <a:off x="8229600" y="2852928"/>
-            <a:ext cx="457200" cy="274320"/>
-          </a:xfrm>
-          <a:prstGeom prst="rect">
-            <a:avLst/>
-          </a:prstGeom>
-          <a:noFill/>
-          <a:ln/>
-        </p:spPr>
-        <p:txBody>
-          <a:bodyPr wrap="square" lIns="0" tIns="0" rIns="0" bIns="0" rtlCol="0" anchor="t"/>
-          <a:lstStyle/>
-          <a:p>
-            <a:pPr indent="0" marL="0">
-              <a:buNone/>
-            </a:pPr>
-            <a:r>
-              <a:rPr lang="en-US" sz="1100" b="1" dirty="0">
-                <a:solidFill>
-                  <a:schemeClr val="accent2"/>
-                </a:solidFill>
-              </a:rPr>
-              <a:t>02</a:t>
-            </a:r>
-            <a:endParaRPr lang="en-US" sz="1100" dirty="0"/>
-          </a:p>
-        </p:txBody>
-      </p:sp>
-      <p:sp>
-        <p:nvSpPr>
-          <p:cNvPr id="19" name="Text 17"/>
+            <a:off x="8229600" y="4297680"/>
+            <a:ext cx="1783080" cy="457200"/>
+          </a:xfrm>
+          <a:prstGeom prst="rect">
+            <a:avLst/>
+          </a:prstGeom>
+          <a:noFill/>
+          <a:ln/>
+        </p:spPr>
+        <p:txBody>
+          <a:bodyPr wrap="square" lIns="0" tIns="0" rIns="0" bIns="0" rtlCol="0" anchor="ctr"/>
+          <a:lstStyle/>
+          <a:p>
+            <a:pPr indent="0" marL="0">
+              <a:buNone/>
+            </a:pPr>
+            <a:r>
+              <a:rPr lang="en-US" sz="2000" b="1" dirty="0">
+                <a:solidFill>
+                  <a:schemeClr val="bg1"/>
+                </a:solidFill>
+                <a:latin typeface="Century Gothic" pitchFamily="34" charset="0"/>
+                <a:ea typeface="Century Gothic" pitchFamily="34" charset="-122"/>
+                <a:cs typeface="Century Gothic" pitchFamily="34" charset="-120"/>
+              </a:rPr>
+              <a:t>₹64.8 lakh</a:t>
+            </a:r>
+            <a:endParaRPr lang="en-US" sz="2000" dirty="0"/>
+          </a:p>
+        </p:txBody>
+      </p:sp>
+      <p:sp>
+        <p:nvSpPr>
+          <p:cNvPr id="30" name="Text 24"/>
           <p:cNvSpPr txBox="1"/>
           <p:nvPr/>
         </p:nvSpPr>
         <p:spPr>
           <a:xfrm>
-            <a:off x="8732520" y="2807208"/>
-            <a:ext cx="2926080" cy="365760"/>
-          </a:xfrm>
-          <a:prstGeom prst="rect">
-            <a:avLst/>
-          </a:prstGeom>
-          <a:noFill/>
-          <a:ln/>
-        </p:spPr>
-        <p:txBody>
-          <a:bodyPr wrap="square" lIns="0" tIns="0" rIns="0" bIns="0" rtlCol="0" anchor="t"/>
-          <a:lstStyle/>
-          <a:p>
-            <a:pPr indent="0" marL="0">
-              <a:buNone/>
-            </a:pPr>
-            <a:r>
-              <a:rPr lang="en-US" sz="2000" b="1" dirty="0">
-                <a:solidFill>
-                  <a:schemeClr val="bg1"/>
-                </a:solidFill>
-              </a:rPr>
-              <a:t>PRICE</a:t>
-            </a:r>
-            <a:endParaRPr lang="en-US" sz="2000" dirty="0"/>
-          </a:p>
-        </p:txBody>
-      </p:sp>
-      <p:sp>
-        <p:nvSpPr>
-          <p:cNvPr id="20" name="Text 18"/>
-          <p:cNvSpPr txBox="1"/>
-          <p:nvPr/>
-        </p:nvSpPr>
-        <p:spPr>
-          <a:xfrm>
-            <a:off x="8732520" y="3218688"/>
-            <a:ext cx="2926080" cy="502920"/>
-          </a:xfrm>
-          <a:prstGeom prst="rect">
-            <a:avLst/>
-          </a:prstGeom>
-          <a:noFill/>
-          <a:ln/>
-        </p:spPr>
-        <p:txBody>
-          <a:bodyPr wrap="square" lIns="0" tIns="0" rIns="0" bIns="0" rtlCol="0" anchor="t"/>
-          <a:lstStyle/>
-          <a:p>
-            <a:pPr indent="0" marL="0">
-              <a:buNone/>
-            </a:pPr>
-            <a:r>
-              <a:rPr lang="en-US" sz="1200" dirty="0">
+            <a:off x="10058400" y="4297680"/>
+            <a:ext cx="1691640" cy="457200"/>
+          </a:xfrm>
+          <a:prstGeom prst="rect">
+            <a:avLst/>
+          </a:prstGeom>
+          <a:noFill/>
+          <a:ln/>
+        </p:spPr>
+        <p:txBody>
+          <a:bodyPr wrap="square" lIns="0" tIns="0" rIns="0" bIns="0" rtlCol="0" anchor="ctr"/>
+          <a:lstStyle/>
+          <a:p>
+            <a:pPr indent="0" marL="0">
+              <a:buNone/>
+            </a:pPr>
+            <a:r>
+              <a:rPr lang="en-US" sz="900" b="1" dirty="0">
                 <a:solidFill>
                   <a:schemeClr val="accent6"/>
                 </a:solidFill>
               </a:rPr>
-              <a:t>All three trade above our blended value, so we buy slowly, through a SIP</a:t>
-            </a:r>
-            <a:endParaRPr lang="en-US" sz="1200" dirty="0"/>
-          </a:p>
-        </p:txBody>
-      </p:sp>
-      <p:sp>
-        <p:nvSpPr>
-          <p:cNvPr id="21" name="Shape 19"/>
+              <a:t>MEDIAN 15-YEAR CORPUS FROM A ₹10,000 MONTHLY SIP</a:t>
+            </a:r>
+            <a:endParaRPr lang="en-US" sz="900" dirty="0"/>
+          </a:p>
+        </p:txBody>
+      </p:sp>
+      <p:sp>
+        <p:nvSpPr>
+          <p:cNvPr id="31" name="Shape 25"/>
           <p:cNvSpPr/>
           <p:nvPr/>
         </p:nvSpPr>
         <p:spPr>
           <a:xfrm>
-            <a:off x="8229600" y="3794760"/>
-            <a:ext cx="3410712" cy="0"/>
+            <a:off x="8229600" y="4919472"/>
+            <a:ext cx="3520440" cy="0"/>
           </a:xfrm>
           <a:prstGeom prst="line">
             <a:avLst/>
@@ -4826,122 +5361,89 @@
       </p:sp>
       <p:sp>
         <p:nvSpPr>
-          <p:cNvPr id="22" name="Text 20"/>
+          <p:cNvPr id="32" name="Text 26"/>
           <p:cNvSpPr txBox="1"/>
           <p:nvPr/>
         </p:nvSpPr>
         <p:spPr>
           <a:xfrm>
-            <a:off x="8229600" y="3968496"/>
-            <a:ext cx="457200" cy="274320"/>
-          </a:xfrm>
-          <a:prstGeom prst="rect">
-            <a:avLst/>
-          </a:prstGeom>
-          <a:noFill/>
-          <a:ln/>
-        </p:spPr>
-        <p:txBody>
-          <a:bodyPr wrap="square" lIns="0" tIns="0" rIns="0" bIns="0" rtlCol="0" anchor="t"/>
-          <a:lstStyle/>
-          <a:p>
-            <a:pPr indent="0" marL="0">
-              <a:buNone/>
-            </a:pPr>
-            <a:r>
-              <a:rPr lang="en-US" sz="1100" b="1" dirty="0">
-                <a:solidFill>
-                  <a:schemeClr val="accent2"/>
-                </a:solidFill>
-              </a:rPr>
-              <a:t>03</a:t>
-            </a:r>
-            <a:endParaRPr lang="en-US" sz="1100" dirty="0"/>
-          </a:p>
-        </p:txBody>
-      </p:sp>
-      <p:sp>
-        <p:nvSpPr>
-          <p:cNvPr id="23" name="Text 21"/>
+            <a:off x="8229600" y="5010912"/>
+            <a:ext cx="1783080" cy="457200"/>
+          </a:xfrm>
+          <a:prstGeom prst="rect">
+            <a:avLst/>
+          </a:prstGeom>
+          <a:noFill/>
+          <a:ln/>
+        </p:spPr>
+        <p:txBody>
+          <a:bodyPr wrap="square" lIns="0" tIns="0" rIns="0" bIns="0" rtlCol="0" anchor="ctr"/>
+          <a:lstStyle/>
+          <a:p>
+            <a:pPr indent="0" marL="0">
+              <a:buNone/>
+            </a:pPr>
+            <a:r>
+              <a:rPr lang="en-US" sz="2000" b="1" dirty="0">
+                <a:solidFill>
+                  <a:schemeClr val="bg1"/>
+                </a:solidFill>
+                <a:latin typeface="Century Gothic" pitchFamily="34" charset="0"/>
+                <a:ea typeface="Century Gothic" pitchFamily="34" charset="-122"/>
+                <a:cs typeface="Century Gothic" pitchFamily="34" charset="-120"/>
+              </a:rPr>
+              <a:t>44 / 47</a:t>
+            </a:r>
+            <a:endParaRPr lang="en-US" sz="2000" dirty="0"/>
+          </a:p>
+        </p:txBody>
+      </p:sp>
+      <p:sp>
+        <p:nvSpPr>
+          <p:cNvPr id="33" name="Text 27"/>
           <p:cNvSpPr txBox="1"/>
           <p:nvPr/>
         </p:nvSpPr>
         <p:spPr>
           <a:xfrm>
-            <a:off x="8732520" y="3922776"/>
-            <a:ext cx="2926080" cy="365760"/>
-          </a:xfrm>
-          <a:prstGeom prst="rect">
-            <a:avLst/>
-          </a:prstGeom>
-          <a:noFill/>
-          <a:ln/>
-        </p:spPr>
-        <p:txBody>
-          <a:bodyPr wrap="square" lIns="0" tIns="0" rIns="0" bIns="0" rtlCol="0" anchor="t"/>
-          <a:lstStyle/>
-          <a:p>
-            <a:pPr indent="0" marL="0">
-              <a:buNone/>
-            </a:pPr>
-            <a:r>
-              <a:rPr lang="en-US" sz="2000" b="1" dirty="0">
-                <a:solidFill>
-                  <a:schemeClr val="bg1"/>
-                </a:solidFill>
-              </a:rPr>
-              <a:t>PORTFOLIO</a:t>
-            </a:r>
-            <a:endParaRPr lang="en-US" sz="2000" dirty="0"/>
-          </a:p>
-        </p:txBody>
-      </p:sp>
-      <p:sp>
-        <p:nvSpPr>
-          <p:cNvPr id="24" name="Text 22"/>
-          <p:cNvSpPr txBox="1"/>
-          <p:nvPr/>
-        </p:nvSpPr>
-        <p:spPr>
-          <a:xfrm>
-            <a:off x="8732520" y="4334256"/>
-            <a:ext cx="2926080" cy="502920"/>
-          </a:xfrm>
-          <a:prstGeom prst="rect">
-            <a:avLst/>
-          </a:prstGeom>
-          <a:noFill/>
-          <a:ln/>
-        </p:spPr>
-        <p:txBody>
-          <a:bodyPr wrap="square" lIns="0" tIns="0" rIns="0" bIns="0" rtlCol="0" anchor="t"/>
-          <a:lstStyle/>
-          <a:p>
-            <a:pPr indent="0" marL="0">
-              <a:buNone/>
-            </a:pPr>
-            <a:r>
-              <a:rPr lang="en-US" sz="1200" dirty="0">
+            <a:off x="10058400" y="5010912"/>
+            <a:ext cx="1691640" cy="457200"/>
+          </a:xfrm>
+          <a:prstGeom prst="rect">
+            <a:avLst/>
+          </a:prstGeom>
+          <a:noFill/>
+          <a:ln/>
+        </p:spPr>
+        <p:txBody>
+          <a:bodyPr wrap="square" lIns="0" tIns="0" rIns="0" bIns="0" rtlCol="0" anchor="ctr"/>
+          <a:lstStyle/>
+          <a:p>
+            <a:pPr indent="0" marL="0">
+              <a:buNone/>
+            </a:pPr>
+            <a:r>
+              <a:rPr lang="en-US" sz="900" b="1" dirty="0">
                 <a:solidFill>
                   <a:schemeClr val="accent6"/>
                 </a:solidFill>
               </a:rPr>
-              <a:t>31 · 19 · 50 satellite around a Nifty 50 index core</a:t>
-            </a:r>
-            <a:endParaRPr lang="en-US" sz="1200" dirty="0"/>
-          </a:p>
-        </p:txBody>
-      </p:sp>
-      <p:sp>
-        <p:nvSpPr>
-          <p:cNvPr id="25" name="Shape 23"/>
+              <a:t>AI-EXTRACTED FIGURES WITHIN 1% OF YAHOO AND SCREENER</a:t>
+            </a:r>
+            <a:endParaRPr lang="en-US" sz="900" dirty="0"/>
+          </a:p>
+        </p:txBody>
+      </p:sp>
+      <p:sp>
+        <p:nvSpPr>
+          <p:cNvPr id="34" name="Shape 28"/>
           <p:cNvSpPr/>
           <p:nvPr/>
         </p:nvSpPr>
         <p:spPr>
           <a:xfrm>
-            <a:off x="8229600" y="4910328"/>
-            <a:ext cx="3410712" cy="0"/>
+            <a:off x="8229600" y="5632704"/>
+            <a:ext cx="3520440" cy="0"/>
           </a:xfrm>
           <a:prstGeom prst="line">
             <a:avLst/>
@@ -4954,6 +5456,81 @@
             <a:prstDash val="solid"/>
           </a:ln>
         </p:spPr>
+      </p:sp>
+      <p:sp>
+        <p:nvSpPr>
+          <p:cNvPr id="35" name="Text 29"/>
+          <p:cNvSpPr txBox="1"/>
+          <p:nvPr/>
+        </p:nvSpPr>
+        <p:spPr>
+          <a:xfrm>
+            <a:off x="8229600" y="5724144"/>
+            <a:ext cx="1783080" cy="457200"/>
+          </a:xfrm>
+          <a:prstGeom prst="rect">
+            <a:avLst/>
+          </a:prstGeom>
+          <a:noFill/>
+          <a:ln/>
+        </p:spPr>
+        <p:txBody>
+          <a:bodyPr wrap="square" lIns="0" tIns="0" rIns="0" bIns="0" rtlCol="0" anchor="ctr"/>
+          <a:lstStyle/>
+          <a:p>
+            <a:pPr indent="0" marL="0">
+              <a:buNone/>
+            </a:pPr>
+            <a:r>
+              <a:rPr lang="en-US" sz="2000" b="1" dirty="0">
+                <a:solidFill>
+                  <a:schemeClr val="bg1"/>
+                </a:solidFill>
+                <a:latin typeface="Century Gothic" pitchFamily="34" charset="0"/>
+                <a:ea typeface="Century Gothic" pitchFamily="34" charset="-122"/>
+                <a:cs typeface="Century Gothic" pitchFamily="34" charset="-120"/>
+              </a:rPr>
+              <a:t>0 of 8</a:t>
+            </a:r>
+            <a:endParaRPr lang="en-US" sz="2000" dirty="0"/>
+          </a:p>
+        </p:txBody>
+      </p:sp>
+      <p:sp>
+        <p:nvSpPr>
+          <p:cNvPr id="36" name="Text 30"/>
+          <p:cNvSpPr txBox="1"/>
+          <p:nvPr/>
+        </p:nvSpPr>
+        <p:spPr>
+          <a:xfrm>
+            <a:off x="10058400" y="5724144"/>
+            <a:ext cx="1691640" cy="457200"/>
+          </a:xfrm>
+          <a:prstGeom prst="rect">
+            <a:avLst/>
+          </a:prstGeom>
+          <a:noFill/>
+          <a:ln/>
+        </p:spPr>
+        <p:txBody>
+          <a:bodyPr wrap="square" lIns="0" tIns="0" rIns="0" bIns="0" rtlCol="0" anchor="ctr"/>
+          <a:lstStyle/>
+          <a:p>
+            <a:pPr indent="0" marL="0">
+              <a:buNone/>
+            </a:pPr>
+            <a:r>
+              <a:rPr lang="en-US" sz="900" b="1" dirty="0">
+                <a:solidFill>
+                  <a:schemeClr val="accent6"/>
+                </a:solidFill>
+              </a:rPr>
+              <a:t>TRADING RULES THAT BEAT BUY-AND-HOLD AFTER COSTS</a:t>
+            </a:r>
+            <a:endParaRPr lang="en-US" sz="900" dirty="0"/>
+          </a:p>
+        </p:txBody>
       </p:sp>
     </p:spTree>
   </p:cSld>
@@ -7422,6 +7999,9 @@
                 <a:solidFill>
                   <a:schemeClr val="accent1"/>
                 </a:solidFill>
+                <a:latin typeface="Century Gothic" pitchFamily="34" charset="0"/>
+                <a:ea typeface="Century Gothic" pitchFamily="34" charset="-122"/>
+                <a:cs typeface="Century Gothic" pitchFamily="34" charset="-120"/>
               </a:rPr>
               <a:t>32%</a:t>
             </a:r>
@@ -7508,6 +8088,9 @@
                 <a:solidFill>
                   <a:schemeClr val="accent1"/>
                 </a:solidFill>
+                <a:latin typeface="Century Gothic" pitchFamily="34" charset="0"/>
+                <a:ea typeface="Century Gothic" pitchFamily="34" charset="-122"/>
+                <a:cs typeface="Century Gothic" pitchFamily="34" charset="-120"/>
               </a:rPr>
               <a:t>11%</a:t>
             </a:r>
@@ -7594,6 +8177,9 @@
                 <a:solidFill>
                   <a:schemeClr val="accent1"/>
                 </a:solidFill>
+                <a:latin typeface="Century Gothic" pitchFamily="34" charset="0"/>
+                <a:ea typeface="Century Gothic" pitchFamily="34" charset="-122"/>
+                <a:cs typeface="Century Gothic" pitchFamily="34" charset="-120"/>
               </a:rPr>
               <a:t>57%</a:t>
             </a:r>
@@ -9872,6 +10458,9 @@
                 <a:solidFill>
                   <a:schemeClr val="accent1"/>
                 </a:solidFill>
+                <a:latin typeface="Century Gothic" pitchFamily="34" charset="0"/>
+                <a:ea typeface="Century Gothic" pitchFamily="34" charset="-122"/>
+                <a:cs typeface="Century Gothic" pitchFamily="34" charset="-120"/>
               </a:rPr>
               <a:t>7.8%</a:t>
             </a:r>
@@ -9969,6 +10558,9 @@
                 <a:solidFill>
                   <a:schemeClr val="accent1"/>
                 </a:solidFill>
+                <a:latin typeface="Century Gothic" pitchFamily="34" charset="0"/>
+                <a:ea typeface="Century Gothic" pitchFamily="34" charset="-122"/>
+                <a:cs typeface="Century Gothic" pitchFamily="34" charset="-120"/>
               </a:rPr>
               <a:t>+11.9%</a:t>
             </a:r>
@@ -10066,6 +10658,9 @@
                 <a:solidFill>
                   <a:schemeClr val="accent1"/>
                 </a:solidFill>
+                <a:latin typeface="Century Gothic" pitchFamily="34" charset="0"/>
+                <a:ea typeface="Century Gothic" pitchFamily="34" charset="-122"/>
+                <a:cs typeface="Century Gothic" pitchFamily="34" charset="-120"/>
               </a:rPr>
               <a:t>5.25%</a:t>
             </a:r>
@@ -10163,6 +10758,9 @@
                 <a:solidFill>
                   <a:schemeClr val="accent1"/>
                 </a:solidFill>
+                <a:latin typeface="Century Gothic" pitchFamily="34" charset="0"/>
+                <a:ea typeface="Century Gothic" pitchFamily="34" charset="-122"/>
+                <a:cs typeface="Century Gothic" pitchFamily="34" charset="-120"/>
               </a:rPr>
               <a:t>5.52%</a:t>
             </a:r>
@@ -10961,6 +11559,9 @@
                 <a:solidFill>
                   <a:schemeClr val="bg1"/>
                 </a:solidFill>
+                <a:latin typeface="Century Gothic" pitchFamily="34" charset="0"/>
+                <a:ea typeface="Century Gothic" pitchFamily="34" charset="-122"/>
+                <a:cs typeface="Century Gothic" pitchFamily="34" charset="-120"/>
               </a:rPr>
               <a:t>0.16–0.24</a:t>
             </a:r>
@@ -11539,6 +12140,9 @@
                 <a:solidFill>
                   <a:schemeClr val="accent3"/>
                 </a:solidFill>
+                <a:latin typeface="Century Gothic" pitchFamily="34" charset="0"/>
+                <a:ea typeface="Century Gothic" pitchFamily="34" charset="-122"/>
+                <a:cs typeface="Century Gothic" pitchFamily="34" charset="-120"/>
               </a:rPr>
               <a:t>−14%</a:t>
             </a:r>
@@ -11661,6 +12265,9 @@
                 <a:solidFill>
                   <a:schemeClr val="accent1"/>
                 </a:solidFill>
+                <a:latin typeface="Century Gothic" pitchFamily="34" charset="0"/>
+                <a:ea typeface="Century Gothic" pitchFamily="34" charset="-122"/>
+                <a:cs typeface="Century Gothic" pitchFamily="34" charset="-120"/>
               </a:rPr>
               <a:t>−30%</a:t>
             </a:r>
@@ -11783,6 +12390,9 @@
                 <a:solidFill>
                   <a:schemeClr val="accent1"/>
                 </a:solidFill>
+                <a:latin typeface="Century Gothic" pitchFamily="34" charset="0"/>
+                <a:ea typeface="Century Gothic" pitchFamily="34" charset="-122"/>
+                <a:cs typeface="Century Gothic" pitchFamily="34" charset="-120"/>
               </a:rPr>
               <a:t>−37%</a:t>
             </a:r>
@@ -12409,6 +13019,9 @@
                 <a:solidFill>
                   <a:schemeClr val="accent1"/>
                 </a:solidFill>
+                <a:latin typeface="Century Gothic" pitchFamily="34" charset="0"/>
+                <a:ea typeface="Century Gothic" pitchFamily="34" charset="-122"/>
+                <a:cs typeface="Century Gothic" pitchFamily="34" charset="-120"/>
               </a:rPr>
               <a:t>44 / 47</a:t>
             </a:r>
@@ -12704,6 +13317,9 @@
                 <a:solidFill>
                   <a:schemeClr val="accent1"/>
                 </a:solidFill>
+                <a:latin typeface="Century Gothic" pitchFamily="34" charset="0"/>
+                <a:ea typeface="Century Gothic" pitchFamily="34" charset="-122"/>
+                <a:cs typeface="Century Gothic" pitchFamily="34" charset="-120"/>
               </a:rPr>
               <a:t>+0.28</a:t>
             </a:r>
@@ -12999,6 +13615,9 @@
                 <a:solidFill>
                   <a:schemeClr val="accent1"/>
                 </a:solidFill>
+                <a:latin typeface="Century Gothic" pitchFamily="34" charset="0"/>
+                <a:ea typeface="Century Gothic" pitchFamily="34" charset="-122"/>
+                <a:cs typeface="Century Gothic" pitchFamily="34" charset="-120"/>
               </a:rPr>
               <a:t>41%</a:t>
             </a:r>
@@ -13294,6 +13913,9 @@
                 <a:solidFill>
                   <a:schemeClr val="accent1"/>
                 </a:solidFill>
+                <a:latin typeface="Century Gothic" pitchFamily="34" charset="0"/>
+                <a:ea typeface="Century Gothic" pitchFamily="34" charset="-122"/>
+                <a:cs typeface="Century Gothic" pitchFamily="34" charset="-120"/>
               </a:rPr>
               <a:t>0 of 8</a:t>
             </a:r>
@@ -13589,6 +14211,9 @@
                 <a:solidFill>
                   <a:schemeClr val="accent1"/>
                 </a:solidFill>
+                <a:latin typeface="Century Gothic" pitchFamily="34" charset="0"/>
+                <a:ea typeface="Century Gothic" pitchFamily="34" charset="-122"/>
+                <a:cs typeface="Century Gothic" pitchFamily="34" charset="-120"/>
               </a:rPr>
               <a:t>57%</a:t>
             </a:r>
@@ -14635,6 +15260,9 @@
                 <a:solidFill>
                   <a:schemeClr val="bg1"/>
                 </a:solidFill>
+                <a:latin typeface="Century Gothic" pitchFamily="34" charset="0"/>
+                <a:ea typeface="Century Gothic" pitchFamily="34" charset="-122"/>
+                <a:cs typeface="Century Gothic" pitchFamily="34" charset="-120"/>
               </a:rPr>
               <a:t>0 OF 8</a:t>
             </a:r>
@@ -14802,6 +15430,9 @@
                 <a:solidFill>
                   <a:schemeClr val="bg1"/>
                 </a:solidFill>
+                <a:latin typeface="Century Gothic" pitchFamily="34" charset="0"/>
+                <a:ea typeface="Century Gothic" pitchFamily="34" charset="-122"/>
+                <a:cs typeface="Century Gothic" pitchFamily="34" charset="-120"/>
               </a:rPr>
               <a:t>+1.2% / −1.6%</a:t>
             </a:r>
@@ -15057,7 +15688,7 @@
                   <a:schemeClr val="accent1"/>
                 </a:solidFill>
               </a:rPr>
-              <a:t>31 · 19 · 50, SIZED TO EACH INVESTOR</a:t>
+              <a:t>31 / 19 / 50, SIZED TO EACH INVESTOR</a:t>
             </a:r>
             <a:endParaRPr lang="en-US" sz="2800" dirty="0"/>
           </a:p>
@@ -15204,6 +15835,9 @@
                 <a:solidFill>
                   <a:schemeClr val="accent1"/>
                 </a:solidFill>
+                <a:latin typeface="Century Gothic" pitchFamily="34" charset="0"/>
+                <a:ea typeface="Century Gothic" pitchFamily="34" charset="-122"/>
+                <a:cs typeface="Century Gothic" pitchFamily="34" charset="-120"/>
               </a:rPr>
               <a:t>87%</a:t>
             </a:r>
@@ -15365,6 +15999,9 @@
                 <a:solidFill>
                   <a:schemeClr val="tx1"/>
                 </a:solidFill>
+                <a:latin typeface="Century Gothic" pitchFamily="34" charset="0"/>
+                <a:ea typeface="Century Gothic" pitchFamily="34" charset="-122"/>
+                <a:cs typeface="Century Gothic" pitchFamily="34" charset="-120"/>
               </a:rPr>
               <a:t>44%</a:t>
             </a:r>
@@ -15526,6 +16163,9 @@
                 <a:solidFill>
                   <a:schemeClr val="accent3"/>
                 </a:solidFill>
+                <a:latin typeface="Century Gothic" pitchFamily="34" charset="0"/>
+                <a:ea typeface="Century Gothic" pitchFamily="34" charset="-122"/>
+                <a:cs typeface="Century Gothic" pitchFamily="34" charset="-120"/>
               </a:rPr>
               <a:t>29%</a:t>
             </a:r>
@@ -16218,6 +16858,9 @@
                 <a:solidFill>
                   <a:schemeClr val="accent1"/>
                 </a:solidFill>
+                <a:latin typeface="Century Gothic" pitchFamily="34" charset="0"/>
+                <a:ea typeface="Century Gothic" pitchFamily="34" charset="-122"/>
+                <a:cs typeface="Century Gothic" pitchFamily="34" charset="-120"/>
               </a:rPr>
               <a:t>₹38.1 lakh</a:t>
             </a:r>
@@ -16315,6 +16958,9 @@
                 <a:solidFill>
                   <a:schemeClr val="accent1"/>
                 </a:solidFill>
+                <a:latin typeface="Century Gothic" pitchFamily="34" charset="0"/>
+                <a:ea typeface="Century Gothic" pitchFamily="34" charset="-122"/>
+                <a:cs typeface="Century Gothic" pitchFamily="34" charset="-120"/>
               </a:rPr>
               <a:t>₹64.8 lakh</a:t>
             </a:r>
@@ -16412,6 +17058,9 @@
                 <a:solidFill>
                   <a:schemeClr val="accent1"/>
                 </a:solidFill>
+                <a:latin typeface="Century Gothic" pitchFamily="34" charset="0"/>
+                <a:ea typeface="Century Gothic" pitchFamily="34" charset="-122"/>
+                <a:cs typeface="Century Gothic" pitchFamily="34" charset="-120"/>
               </a:rPr>
               <a:t>19% / 11%</a:t>
             </a:r>
@@ -16789,6 +17438,9 @@
                 <a:solidFill>
                   <a:schemeClr val="accent2"/>
                 </a:solidFill>
+                <a:latin typeface="Century Gothic" pitchFamily="34" charset="0"/>
+                <a:ea typeface="Century Gothic" pitchFamily="34" charset="-122"/>
+                <a:cs typeface="Century Gothic" pitchFamily="34" charset="-120"/>
               </a:rPr>
               <a:t>BUY</a:t>
             </a:r>
@@ -16897,6 +17549,9 @@
                 <a:solidFill>
                   <a:schemeClr val="bg1"/>
                 </a:solidFill>
+                <a:latin typeface="Century Gothic" pitchFamily="34" charset="0"/>
+                <a:ea typeface="Century Gothic" pitchFamily="34" charset="-122"/>
+                <a:cs typeface="Century Gothic" pitchFamily="34" charset="-120"/>
               </a:rPr>
               <a:t>HOLD</a:t>
             </a:r>
@@ -17005,6 +17660,9 @@
                 <a:solidFill>
                   <a:schemeClr val="bg1"/>
                 </a:solidFill>
+                <a:latin typeface="Century Gothic" pitchFamily="34" charset="0"/>
+                <a:ea typeface="Century Gothic" pitchFamily="34" charset="-122"/>
+                <a:cs typeface="Century Gothic" pitchFamily="34" charset="-120"/>
               </a:rPr>
               <a:t>HOLD</a:t>
             </a:r>
@@ -17077,6 +17735,9 @@
                 <a:solidFill>
                   <a:schemeClr val="accent1"/>
                 </a:solidFill>
+                <a:latin typeface="Century Gothic" pitchFamily="34" charset="0"/>
+                <a:ea typeface="Century Gothic" pitchFamily="34" charset="-122"/>
+                <a:cs typeface="Century Gothic" pitchFamily="34" charset="-120"/>
               </a:rPr>
               <a:t>BUY THE PORTFOLIO SLOWLY, THROUGH THE SIP</a:t>
             </a:r>
@@ -17596,7 +18257,7 @@
     </a:clrScheme>
     <a:fontScheme name="SA Portfolio">
       <a:majorFont>
-        <a:latin typeface="Arial"/>
+        <a:latin typeface="Century Gothic"/>
         <a:ea typeface=""/>
         <a:cs typeface=""/>
         <a:font script="Jpan" typeface="游ゴシック Light"/>
@@ -17648,7 +18309,7 @@
         <a:font script="Tfng" typeface="Ebrima"/>
       </a:majorFont>
       <a:minorFont>
-        <a:latin typeface="Arial"/>
+        <a:latin typeface="Calibri"/>
         <a:ea typeface=""/>
         <a:cs typeface=""/>
         <a:font script="Jpan" typeface="游ゴシック"/>

</xml_diff>